<commit_message>
fix: rewrite presentation deck to match shipped architecture, add taxonomy-correction centerpiece
The deck (Aug 24) described a four-strategy parallel retrieval tournament with
exact-judged-query-only scope — a design the outline's own "What actually
shipped" section confirms was superseded by a single hybrid retrieval pass
with dynamic alpha and one bounded retry. It also had zero content on
taxonomy self-correction, despite the outline calling it the talk's
centerpiece.

Rewrites slides 3-4, 6-12, and 16 to match the real pipeline (intent
classifier -> query evaluator -> retriever -> reranker -> quality gate ->
agent -> LLM judge), adds a dedicated taxonomy self-correction slide and a
Workbench context-switch slide (16 -> 18 slides), moves Guarantees earlier,
and reorders Baseline before Thesis so the thesis lands after its setup.

Closes #81
Closes #79

Co-Authored-By: Claude Sonnet 5 <noreply@anthropic.com>
Claude-Session: https://claude.ai/code/session_01T5zt2RtP9GE3rwSxGUvNYx
</commit_message>
<xml_diff>
--- a/docs/presentation/Agentic Search Talk Draft.pptx
+++ b/docs/presentation/Agentic Search Talk Draft.pptx
@@ -10,15 +10,17 @@
   <p:sldIdLst>
     <p:sldId id="256" r:id="rId6"/>
     <p:sldId id="275" r:id="rId25"/>
+    <p:sldId id="276" r:id="rId26"/>
     <p:sldId id="258" r:id="rId8"/>
     <p:sldId id="259" r:id="rId9"/>
-    <p:sldId id="276" r:id="rId26"/>
     <p:sldId id="277" r:id="rId27"/>
+    <p:sldId id="270" r:id="rId20"/>
     <p:sldId id="273" r:id="rId23"/>
+    <p:sldId id="278" r:id="rId19"/>
     <p:sldId id="267" r:id="rId17"/>
     <p:sldId id="262" r:id="rId12"/>
     <p:sldId id="263" r:id="rId13"/>
-    <p:sldId id="270" r:id="rId20"/>
+    <p:sldId id="279" r:id="rId18"/>
     <p:sldId id="264" r:id="rId14"/>
     <p:sldId id="265" r:id="rId15"/>
     <p:sldId id="260" r:id="rId10"/>
@@ -12036,7 +12038,7 @@
                 <a:cs typeface="Calibri"/>
                 <a:sym typeface="Calibri"/>
               </a:rPr>
-              <a:t>10 / 16</a:t>
+              <a:t>12 / 18</a:t>
             </a:r>
             <a:endParaRPr/>
           </a:p>
@@ -12488,7 +12490,7 @@
                 <a:cs typeface="Calibri"/>
                 <a:sym typeface="Calibri"/>
               </a:rPr>
-              <a:t>STRATEGY COMPARISON</a:t>
+              <a:t>RETRIEVAL DETAIL</a:t>
             </a:r>
             <a:endParaRPr/>
           </a:p>
@@ -12538,7 +12540,7 @@
                 <a:cs typeface="Calibri"/>
                 <a:sym typeface="Calibri"/>
               </a:rPr>
-              <a:t>Candidates, relevance metrics, reranker movement, latency</a:t>
+              <a:t>Full OpenSearch DSL query — hybrid, BM25 baseline, retry variant — filters, candidate counts</a:t>
             </a:r>
             <a:endParaRPr/>
           </a:p>
@@ -12689,7 +12691,7 @@
                 <a:cs typeface="Calibri"/>
                 <a:sym typeface="Calibri"/>
               </a:rPr>
-              <a:t>Selected strategy, recovery action, reason, measured delta</a:t>
+              <a:t>Intent, α, quality-gate verdict, retry reason</a:t>
             </a:r>
             <a:endParaRPr/>
           </a:p>
@@ -12840,7 +12842,7 @@
                 <a:cs typeface="Calibri"/>
                 <a:sym typeface="Calibri"/>
               </a:rPr>
-              <a:t>Evidence labels, citations, critic result, answer repair</a:t>
+              <a:t>Citations, LLM-judge verdict and hallucination category, auto-correction when it fires</a:t>
             </a:r>
             <a:endParaRPr/>
           </a:p>
@@ -12855,7 +12857,7 @@
         <p:spPr>
           <a:xfrm>
             <a:off x="457200" y="5349240"/>
-            <a:ext cx="5486400" cy="1234440"/>
+            <a:ext cx="3566160" cy="1234440"/>
           </a:xfrm>
           <a:prstGeom prst="rect">
             <a:avLst/>
@@ -12906,7 +12908,7 @@
         <p:spPr>
           <a:xfrm>
             <a:off x="731520" y="5513831"/>
-            <a:ext cx="4937760" cy="274320"/>
+            <a:ext cx="3017520" cy="274320"/>
           </a:xfrm>
           <a:prstGeom prst="rect">
             <a:avLst/>
@@ -12956,7 +12958,7 @@
         <p:spPr>
           <a:xfrm>
             <a:off x="731520" y="5852159"/>
-            <a:ext cx="4937760" cy="640080"/>
+            <a:ext cx="3017520" cy="640080"/>
           </a:xfrm>
           <a:prstGeom prst="rect">
             <a:avLst/>
@@ -12991,7 +12993,309 @@
                 <a:cs typeface="Calibri"/>
                 <a:sym typeface="Calibri"/>
               </a:rPr>
-              <a:t>End-to-end latency; time in retrieval, reranking, generation</a:t>
+              <a:t>End-to-end + per-stage latency</a:t>
+            </a:r>
+            <a:endParaRPr/>
+          </a:p>
+        </p:txBody>
+      </p:sp>
+      <p:sp>
+        <p:nvSpPr>
+          <p:cNvPr id="211" name="Google Shape;208;p20"/>
+          <p:cNvSpPr/>
+          <p:nvPr/>
+        </p:nvSpPr>
+        <p:spPr>
+          <a:xfrm>
+            <a:off x="4297680" y="5349240"/>
+            <a:ext cx="3566160" cy="1234440"/>
+          </a:xfrm>
+          <a:prstGeom prst="rect">
+            <a:avLst/>
+          </a:prstGeom>
+          <a:solidFill>
+            <a:srgbClr val="F8FAFC"/>
+          </a:solidFill>
+          <a:ln>
+            <a:noFill/>
+          </a:ln>
+        </p:spPr>
+        <p:txBody>
+          <a:bodyPr anchorCtr="0" anchor="ctr" bIns="45700" lIns="91425" spcFirstLastPara="1" rIns="91425" wrap="square" tIns="45700">
+            <a:noAutofit/>
+          </a:bodyPr>
+          <a:lstStyle/>
+          <a:p>
+            <a:pPr indent="0" lvl="0" marL="0" marR="0" rtl="0" algn="ctr">
+              <a:spcBef>
+                <a:spcPts val="0"/>
+              </a:spcBef>
+              <a:spcAft>
+                <a:spcPts val="0"/>
+              </a:spcAft>
+              <a:buNone/>
+            </a:pPr>
+            <a:r>
+              <a:t/>
+            </a:r>
+            <a:endParaRPr b="0" i="0" sz="1800" u="none" cap="none" strike="noStrike">
+              <a:solidFill>
+                <a:schemeClr val="dk1"/>
+              </a:solidFill>
+              <a:latin typeface="Calibri"/>
+              <a:ea typeface="Calibri"/>
+              <a:cs typeface="Calibri"/>
+              <a:sym typeface="Calibri"/>
+            </a:endParaRPr>
+          </a:p>
+        </p:txBody>
+      </p:sp>
+      <p:sp>
+        <p:nvSpPr>
+          <p:cNvPr id="212" name="Google Shape;209;p20"/>
+          <p:cNvSpPr txBox="1"/>
+          <p:nvPr/>
+        </p:nvSpPr>
+        <p:spPr>
+          <a:xfrm>
+            <a:off x="4572000" y="5513831"/>
+            <a:ext cx="3017520" cy="274320"/>
+          </a:xfrm>
+          <a:prstGeom prst="rect">
+            <a:avLst/>
+          </a:prstGeom>
+          <a:noFill/>
+          <a:ln>
+            <a:noFill/>
+          </a:ln>
+        </p:spPr>
+        <p:txBody>
+          <a:bodyPr anchorCtr="0" anchor="t" bIns="0" lIns="0" spcFirstLastPara="1" rIns="0" wrap="square" tIns="0">
+            <a:spAutoFit/>
+          </a:bodyPr>
+          <a:lstStyle/>
+          <a:p>
+            <a:pPr indent="0" lvl="0" marL="0" marR="0" rtl="0" algn="l">
+              <a:spcBef>
+                <a:spcPts val="0"/>
+              </a:spcBef>
+              <a:spcAft>
+                <a:spcPts val="0"/>
+              </a:spcAft>
+              <a:buNone/>
+            </a:pPr>
+            <a:r>
+              <a:rPr b="1" i="0" lang="en-US" sz="1300" u="none" cap="none" strike="noStrike">
+                <a:solidFill>
+                  <a:srgbClr val="0369A1"/>
+                </a:solidFill>
+                <a:latin typeface="Calibri"/>
+                <a:ea typeface="Calibri"/>
+                <a:cs typeface="Calibri"/>
+                <a:sym typeface="Calibri"/>
+              </a:rPr>
+              <a:t>PIPELINE QUALITY SUMMARY</a:t>
+            </a:r>
+            <a:endParaRPr/>
+          </a:p>
+        </p:txBody>
+      </p:sp>
+      <p:sp>
+        <p:nvSpPr>
+          <p:cNvPr id="213" name="Google Shape;210;p20"/>
+          <p:cNvSpPr txBox="1"/>
+          <p:nvPr/>
+        </p:nvSpPr>
+        <p:spPr>
+          <a:xfrm>
+            <a:off x="4572000" y="5852159"/>
+            <a:ext cx="3017520" cy="640080"/>
+          </a:xfrm>
+          <a:prstGeom prst="rect">
+            <a:avLst/>
+          </a:prstGeom>
+          <a:noFill/>
+          <a:ln>
+            <a:noFill/>
+          </a:ln>
+        </p:spPr>
+        <p:txBody>
+          <a:bodyPr anchorCtr="0" anchor="t" bIns="0" lIns="0" spcFirstLastPara="1" rIns="0" wrap="square" tIns="0">
+            <a:spAutoFit/>
+          </a:bodyPr>
+          <a:lstStyle/>
+          <a:p>
+            <a:pPr indent="0" lvl="0" marL="0" marR="0" rtl="0" algn="l">
+              <a:spcBef>
+                <a:spcPts val="0"/>
+              </a:spcBef>
+              <a:spcAft>
+                <a:spcPts val="0"/>
+              </a:spcAft>
+              <a:buNone/>
+            </a:pPr>
+            <a:r>
+              <a:rPr b="0" i="0" lang="en-US" sz="1300" u="none" cap="none" strike="noStrike">
+                <a:solidFill>
+                  <a:srgbClr val="475569"/>
+                </a:solidFill>
+                <a:latin typeface="Calibri"/>
+                <a:ea typeface="Calibri"/>
+                <a:cs typeface="Calibri"/>
+                <a:sym typeface="Calibri"/>
+              </a:rPr>
+              <a:t>Real metrics when judged; confidence proxy when not</a:t>
+            </a:r>
+            <a:endParaRPr/>
+          </a:p>
+        </p:txBody>
+      </p:sp>
+      <p:sp>
+        <p:nvSpPr>
+          <p:cNvPr id="214" name="Google Shape;208;p20"/>
+          <p:cNvSpPr/>
+          <p:nvPr/>
+        </p:nvSpPr>
+        <p:spPr>
+          <a:xfrm>
+            <a:off x="8138160" y="5349240"/>
+            <a:ext cx="3566160" cy="1234440"/>
+          </a:xfrm>
+          <a:prstGeom prst="rect">
+            <a:avLst/>
+          </a:prstGeom>
+          <a:solidFill>
+            <a:srgbClr val="F8FAFC"/>
+          </a:solidFill>
+          <a:ln>
+            <a:noFill/>
+          </a:ln>
+        </p:spPr>
+        <p:txBody>
+          <a:bodyPr anchorCtr="0" anchor="ctr" bIns="45700" lIns="91425" spcFirstLastPara="1" rIns="91425" wrap="square" tIns="45700">
+            <a:noAutofit/>
+          </a:bodyPr>
+          <a:lstStyle/>
+          <a:p>
+            <a:pPr indent="0" lvl="0" marL="0" marR="0" rtl="0" algn="ctr">
+              <a:spcBef>
+                <a:spcPts val="0"/>
+              </a:spcBef>
+              <a:spcAft>
+                <a:spcPts val="0"/>
+              </a:spcAft>
+              <a:buNone/>
+            </a:pPr>
+            <a:r>
+              <a:t/>
+            </a:r>
+            <a:endParaRPr b="0" i="0" sz="1800" u="none" cap="none" strike="noStrike">
+              <a:solidFill>
+                <a:schemeClr val="dk1"/>
+              </a:solidFill>
+              <a:latin typeface="Calibri"/>
+              <a:ea typeface="Calibri"/>
+              <a:cs typeface="Calibri"/>
+              <a:sym typeface="Calibri"/>
+            </a:endParaRPr>
+          </a:p>
+        </p:txBody>
+      </p:sp>
+      <p:sp>
+        <p:nvSpPr>
+          <p:cNvPr id="215" name="Google Shape;209;p20"/>
+          <p:cNvSpPr txBox="1"/>
+          <p:nvPr/>
+        </p:nvSpPr>
+        <p:spPr>
+          <a:xfrm>
+            <a:off x="8412480" y="5513831"/>
+            <a:ext cx="3017520" cy="274320"/>
+          </a:xfrm>
+          <a:prstGeom prst="rect">
+            <a:avLst/>
+          </a:prstGeom>
+          <a:noFill/>
+          <a:ln>
+            <a:noFill/>
+          </a:ln>
+        </p:spPr>
+        <p:txBody>
+          <a:bodyPr anchorCtr="0" anchor="t" bIns="0" lIns="0" spcFirstLastPara="1" rIns="0" wrap="square" tIns="0">
+            <a:spAutoFit/>
+          </a:bodyPr>
+          <a:lstStyle/>
+          <a:p>
+            <a:pPr indent="0" lvl="0" marL="0" marR="0" rtl="0" algn="l">
+              <a:spcBef>
+                <a:spcPts val="0"/>
+              </a:spcBef>
+              <a:spcAft>
+                <a:spcPts val="0"/>
+              </a:spcAft>
+              <a:buNone/>
+            </a:pPr>
+            <a:r>
+              <a:rPr b="1" i="0" lang="en-US" sz="1300" u="none" cap="none" strike="noStrike">
+                <a:solidFill>
+                  <a:srgbClr val="0369A1"/>
+                </a:solidFill>
+                <a:latin typeface="Calibri"/>
+                <a:ea typeface="Calibri"/>
+                <a:cs typeface="Calibri"/>
+                <a:sym typeface="Calibri"/>
+              </a:rPr>
+              <a:t>ENRICHMENT CARD</a:t>
+            </a:r>
+            <a:endParaRPr/>
+          </a:p>
+        </p:txBody>
+      </p:sp>
+      <p:sp>
+        <p:nvSpPr>
+          <p:cNvPr id="216" name="Google Shape;210;p20"/>
+          <p:cNvSpPr txBox="1"/>
+          <p:nvPr/>
+        </p:nvSpPr>
+        <p:spPr>
+          <a:xfrm>
+            <a:off x="8412480" y="5852159"/>
+            <a:ext cx="3017520" cy="640080"/>
+          </a:xfrm>
+          <a:prstGeom prst="rect">
+            <a:avLst/>
+          </a:prstGeom>
+          <a:noFill/>
+          <a:ln>
+            <a:noFill/>
+          </a:ln>
+        </p:spPr>
+        <p:txBody>
+          <a:bodyPr anchorCtr="0" anchor="t" bIns="0" lIns="0" spcFirstLastPara="1" rIns="0" wrap="square" tIns="0">
+            <a:spAutoFit/>
+          </a:bodyPr>
+          <a:lstStyle/>
+          <a:p>
+            <a:pPr indent="0" lvl="0" marL="0" marR="0" rtl="0" algn="l">
+              <a:spcBef>
+                <a:spcPts val="0"/>
+              </a:spcBef>
+              <a:spcAft>
+                <a:spcPts val="0"/>
+              </a:spcAft>
+              <a:buNone/>
+            </a:pPr>
+            <a:r>
+              <a:rPr b="0" i="0" lang="en-US" sz="1300" u="none" cap="none" strike="noStrike">
+                <a:solidFill>
+                  <a:srgbClr val="475569"/>
+                </a:solidFill>
+                <a:latin typeface="Calibri"/>
+                <a:ea typeface="Calibri"/>
+                <a:cs typeface="Calibri"/>
+                <a:sym typeface="Calibri"/>
+              </a:rPr>
+              <a:t>Attribute, term, canonical bucket, live re-index status</a:t>
             </a:r>
             <a:endParaRPr/>
           </a:p>
@@ -13073,7 +13377,7 @@
                 <a:cs typeface="Calibri"/>
                 <a:sym typeface="Calibri"/>
               </a:rPr>
-              <a:t>11 / 16</a:t>
+              <a:t>7 / 18</a:t>
             </a:r>
             <a:endParaRPr/>
           </a:p>
@@ -13288,7 +13592,7 @@
                 <a:cs typeface="Calibri"/>
                 <a:sym typeface="Calibri"/>
               </a:rPr>
-              <a:t>Every demo query has an exact match in esci_judgments</a:t>
+              <a:t>Any natural-language query is accepted — no pre-vetted query list</a:t>
             </a:r>
           </a:p>
           <a:p>
@@ -13326,7 +13630,7 @@
                 <a:cs typeface="Calibri"/>
                 <a:sym typeface="Calibri"/>
               </a:rPr>
-              <a:t>Strategies earn their ranking — no judged IDs are injected into retrieval</a:t>
+              <a:t>Retrieval is never seeded with judged product IDs — results are earned by the same hybrid search every query gets</a:t>
             </a:r>
           </a:p>
           <a:p>
@@ -13364,7 +13668,7 @@
                 <a:cs typeface="Calibri"/>
                 <a:sym typeface="Calibri"/>
               </a:rPr>
-              <a:t>Selection is by measured NDCG@10 or MRR, never by model confidence</a:t>
+              <a:t>The quality-gate retry is capped at one, alpha adjusted in the opposite direction</a:t>
             </a:r>
           </a:p>
           <a:p>
@@ -13402,7 +13706,7 @@
                 <a:cs typeface="Calibri"/>
                 <a:sym typeface="Calibri"/>
               </a:rPr>
-              <a:t>The selected attempt improves on the initial strategy</a:t>
+              <a:t>The LLM-judge auto-correction is capped at one, and only for fabrication or cross-product bleed</a:t>
             </a:r>
           </a:p>
         </p:txBody>
@@ -13466,7 +13770,7 @@
                 <a:cs typeface="Calibri"/>
                 <a:sym typeface="Calibri"/>
               </a:rPr>
-              <a:t>No Irrelevant-labeled document reaches the generation context</a:t>
+              <a:t>The taxonomy-correction tool is explicitly feature-flagged (ENABLE_ENRICHMENT_TOOL)</a:t>
             </a:r>
           </a:p>
           <a:p>
@@ -13504,45 +13808,7 @@
                 <a:cs typeface="Calibri"/>
                 <a:sym typeface="Calibri"/>
               </a:rPr>
-              <a:t>Recovery is capped at one additional tournament round</a:t>
-            </a:r>
-          </a:p>
-          <a:p>
-            <a:pPr indent="0" lvl="0" marL="0" marR="0" rtl="0" algn="l">
-              <a:lnSpc>
-                <a:spcPct val="110000"/>
-              </a:lnSpc>
-              <a:spcBef>
-                <a:spcPts val="1200"/>
-              </a:spcBef>
-              <a:spcAft>
-                <a:spcPts val="0"/>
-              </a:spcAft>
-              <a:buNone/>
-            </a:pPr>
-            <a:r>
-              <a:rPr b="1" i="0" lang="en-US" sz="1400" u="none" cap="none" strike="noStrike">
-                <a:solidFill>
-                  <a:srgbClr val="0EA5E9"/>
-                </a:solidFill>
-                <a:latin typeface="Calibri"/>
-                <a:ea typeface="Calibri"/>
-                <a:cs typeface="Calibri"/>
-                <a:sym typeface="Calibri"/>
-              </a:rPr>
-              <a:t>•  </a:t>
-            </a:r>
-            <a:r>
-              <a:rPr b="0" i="0" lang="en-US" sz="1400" u="none" cap="none" strike="noStrike">
-                <a:solidFill>
-                  <a:srgbClr val="475569"/>
-                </a:solidFill>
-                <a:latin typeface="Calibri"/>
-                <a:ea typeface="Calibri"/>
-                <a:cs typeface="Calibri"/>
-                <a:sym typeface="Calibri"/>
-              </a:rPr>
-              <a:t>Answer regeneration is capped at one repair</a:t>
+              <a:t>It fires only from two detected triggers: a filter-exclusion gap, or a shopper's dispute</a:t>
             </a:r>
           </a:p>
           <a:p>
@@ -13661,7 +13927,7 @@
                 <a:cs typeface="Calibri"/>
                 <a:sym typeface="Calibri"/>
               </a:rPr>
-              <a:t>12 / 16</a:t>
+              <a:t>14 / 18</a:t>
             </a:r>
             <a:endParaRPr/>
           </a:p>
@@ -14675,7 +14941,7 @@
                 <a:cs typeface="Calibri"/>
                 <a:sym typeface="Calibri"/>
               </a:rPr>
-              <a:t>13 / 16</a:t>
+              <a:t>15 / 18</a:t>
             </a:r>
             <a:endParaRPr/>
           </a:p>
@@ -15600,7 +15866,7 @@
                 <a:cs typeface="Calibri"/>
                 <a:sym typeface="Calibri"/>
               </a:rPr>
-              <a:t>14 / 16</a:t>
+              <a:t>16 / 18</a:t>
             </a:r>
             <a:endParaRPr/>
           </a:p>
@@ -15786,7 +16052,7 @@
                 <a:spcPct val="110000"/>
               </a:lnSpc>
               <a:spcBef>
-                <a:spcPts val="0"/>
+                <a:spcPts val="1600"/>
               </a:spcBef>
               <a:spcAft>
                 <a:spcPts val="0"/>
@@ -15815,7 +16081,7 @@
                 <a:cs typeface="Calibri"/>
                 <a:sym typeface="Calibri"/>
               </a:rPr>
-              <a:t>The progression:  </a:t>
+              <a:t>The centerpiece:  </a:t>
             </a:r>
             <a:r>
               <a:rPr b="0" i="0" lang="en-US" sz="1700" u="none" cap="none" strike="noStrike">
@@ -15827,7 +16093,7 @@
                 <a:cs typeface="Calibri"/>
                 <a:sym typeface="Calibri"/>
               </a:rPr>
-              <a:t>BM25 → vector → hybrid fusion → reranking → bounded agentic selection.</a:t>
+              <a:t>see an agent fix the catalog, not just the query — the talk's central, differentiating claim.</a:t>
             </a:r>
             <a:endParaRPr/>
           </a:p>
@@ -15837,6 +16103,57 @@
                 <a:spcPct val="110000"/>
               </a:lnSpc>
               <a:spcBef>
+                <a:spcPts val="0"/>
+              </a:spcBef>
+              <a:spcAft>
+                <a:spcPts val="0"/>
+              </a:spcAft>
+              <a:buNone/>
+            </a:pPr>
+            <a:r>
+              <a:rPr b="1" i="0" lang="en-US" sz="1700" u="none" cap="none" strike="noStrike">
+                <a:solidFill>
+                  <a:srgbClr val="0EA5E9"/>
+                </a:solidFill>
+                <a:latin typeface="Calibri"/>
+                <a:ea typeface="Calibri"/>
+                <a:cs typeface="Calibri"/>
+                <a:sym typeface="Calibri"/>
+              </a:rPr>
+              <a:t>•  </a:t>
+            </a:r>
+            <a:r>
+              <a:rPr b="1" i="0" lang="en-US" sz="1700" u="none" cap="none" strike="noStrike">
+                <a:solidFill>
+                  <a:srgbClr val="0A2540"/>
+                </a:solidFill>
+                <a:latin typeface="Calibri"/>
+                <a:ea typeface="Calibri"/>
+                <a:cs typeface="Calibri"/>
+                <a:sym typeface="Calibri"/>
+              </a:rPr>
+              <a:t>The progression:  </a:t>
+            </a:r>
+            <a:r>
+              <a:rPr b="0" i="0" lang="en-US" sz="1700" u="none" cap="none" strike="noStrike">
+                <a:solidFill>
+                  <a:srgbClr val="475569"/>
+                </a:solidFill>
+                <a:latin typeface="Calibri"/>
+                <a:ea typeface="Calibri"/>
+                <a:cs typeface="Calibri"/>
+                <a:sym typeface="Calibri"/>
+              </a:rPr>
+              <a:t>BM25 → vector → hybrid fusion → reranking → dynamic-α retrieval with one bounded retry.</a:t>
+            </a:r>
+            <a:endParaRPr/>
+          </a:p>
+          <a:p>
+            <a:pPr indent="0" lvl="0" marL="0" marR="0" rtl="0" algn="l">
+              <a:lnSpc>
+                <a:spcPct val="110000"/>
+              </a:lnSpc>
+              <a:spcBef>
                 <a:spcPts val="1600"/>
               </a:spcBef>
               <a:spcAft>
@@ -15878,7 +16195,7 @@
                 <a:cs typeface="Calibri"/>
                 <a:sym typeface="Calibri"/>
               </a:rPr>
-              <a:t>a LangGraph application using judgments directly to improve one search and its answer.</a:t>
+              <a:t>a LangGraph application using judgments opportunistically to score one search and its answer — and working just as well without them.</a:t>
             </a:r>
             <a:endParaRPr/>
           </a:p>
@@ -16113,7 +16430,7 @@
                 <a:cs typeface="Calibri"/>
                 <a:sym typeface="Calibri"/>
               </a:rPr>
-              <a:t>15 / 16</a:t>
+              <a:t>17 / 18</a:t>
             </a:r>
             <a:endParaRPr/>
           </a:p>
@@ -17610,6 +17927,950 @@
 </p:sld>
 </file>
 
+<file path=ppt/slides/slide17.xml><?xml version="1.0" encoding="utf-8"?>
+<p:sld xmlns:a="http://schemas.openxmlformats.org/drawingml/2006/main" xmlns:p="http://schemas.openxmlformats.org/presentationml/2006/main" xmlns:r="http://schemas.openxmlformats.org/officeDocument/2006/relationships">
+  <p:cSld>
+    <p:spTree>
+      <p:nvGrpSpPr>
+        <p:cNvPr id="1" name=""/>
+        <p:cNvGrpSpPr/>
+        <p:nvPr/>
+      </p:nvGrpSpPr>
+      <p:grpSpPr/>
+      <p:sp>
+        <p:nvSpPr>
+          <p:cNvPr id="106" name="Google Shape;106;p15"/>
+          <p:cNvSpPr txBox="1"/>
+          <p:nvPr/>
+        </p:nvSpPr>
+        <p:spPr>
+          <a:xfrm>
+            <a:off x="365760" y="228600"/>
+            <a:ext cx="1371600" cy="274320"/>
+          </a:xfrm>
+          <a:prstGeom prst="rect">
+            <a:avLst/>
+          </a:prstGeom>
+          <a:noFill/>
+          <a:ln>
+            <a:noFill/>
+          </a:ln>
+        </p:spPr>
+        <p:txBody>
+          <a:bodyPr anchorCtr="0" anchor="t" bIns="0" lIns="0" spcFirstLastPara="1" rIns="0" wrap="square" tIns="0">
+            <a:spAutoFit/>
+          </a:bodyPr>
+          <a:lstStyle/>
+          <a:p>
+            <a:pPr indent="0" lvl="0" marL="0" marR="0" rtl="0" algn="l">
+              <a:spcBef>
+                <a:spcPts val="0"/>
+              </a:spcBef>
+              <a:spcAft>
+                <a:spcPts val="0"/>
+              </a:spcAft>
+              <a:buNone/>
+            </a:pPr>
+            <a:r>
+              <a:rPr b="0" i="0" lang="en-US" sz="900" u="none" cap="none" strike="noStrike">
+                <a:solidFill>
+                  <a:srgbClr val="94A3B8"/>
+                </a:solidFill>
+                <a:latin typeface="Calibri"/>
+                <a:ea typeface="Calibri"/>
+                <a:cs typeface="Calibri"/>
+                <a:sym typeface="Calibri"/>
+              </a:rPr>
+              <a:t>9 / 18</a:t>
+            </a:r>
+            <a:endParaRPr/>
+          </a:p>
+        </p:txBody>
+      </p:sp>
+      <p:sp>
+        <p:nvSpPr>
+          <p:cNvPr id="107" name="Google Shape;107;p15"/>
+          <p:cNvSpPr txBox="1"/>
+          <p:nvPr/>
+        </p:nvSpPr>
+        <p:spPr>
+          <a:xfrm>
+            <a:off x="1737360" y="228600"/>
+            <a:ext cx="10058400" cy="274320"/>
+          </a:xfrm>
+          <a:prstGeom prst="rect">
+            <a:avLst/>
+          </a:prstGeom>
+          <a:noFill/>
+          <a:ln>
+            <a:noFill/>
+          </a:ln>
+        </p:spPr>
+        <p:txBody>
+          <a:bodyPr anchorCtr="0" anchor="t" bIns="0" lIns="0" spcFirstLastPara="1" rIns="0" wrap="square" tIns="0">
+            <a:spAutoFit/>
+          </a:bodyPr>
+          <a:lstStyle/>
+          <a:p>
+            <a:pPr indent="0" lvl="0" marL="0" marR="0" rtl="0" algn="l">
+              <a:spcBef>
+                <a:spcPts val="0"/>
+              </a:spcBef>
+              <a:spcAft>
+                <a:spcPts val="0"/>
+              </a:spcAft>
+              <a:buNone/>
+            </a:pPr>
+            <a:r>
+              <a:rPr b="0" i="0" lang="en-US" sz="900" u="none" cap="none" strike="noStrike">
+                <a:solidFill>
+                  <a:srgbClr val="94A3B8"/>
+                </a:solidFill>
+                <a:latin typeface="Calibri"/>
+                <a:ea typeface="Calibri"/>
+                <a:cs typeface="Calibri"/>
+                <a:sym typeface="Calibri"/>
+              </a:rPr>
+              <a:t>OpenSearchCon NA 2026  ·  Agentic Search: Reimagining Search from Ingestion to Relevancy</a:t>
+            </a:r>
+            <a:endParaRPr/>
+          </a:p>
+        </p:txBody>
+      </p:sp>
+      <p:sp>
+        <p:nvSpPr>
+          <p:cNvPr id="108" name="Google Shape;108;p15"/>
+          <p:cNvSpPr txBox="1"/>
+          <p:nvPr/>
+        </p:nvSpPr>
+        <p:spPr>
+          <a:xfrm>
+            <a:off x="457200" y="594360"/>
+            <a:ext cx="11247120" cy="292608"/>
+          </a:xfrm>
+          <a:prstGeom prst="rect">
+            <a:avLst/>
+          </a:prstGeom>
+          <a:noFill/>
+          <a:ln>
+            <a:noFill/>
+          </a:ln>
+        </p:spPr>
+        <p:txBody>
+          <a:bodyPr anchorCtr="0" anchor="t" bIns="0" lIns="0" spcFirstLastPara="1" rIns="0" wrap="square" tIns="0">
+            <a:spAutoFit/>
+          </a:bodyPr>
+          <a:lstStyle/>
+          <a:p>
+            <a:pPr indent="0" lvl="0" marL="0" marR="0" rtl="0" algn="l">
+              <a:spcBef>
+                <a:spcPts val="0"/>
+              </a:spcBef>
+              <a:spcAft>
+                <a:spcPts val="0"/>
+              </a:spcAft>
+              <a:buNone/>
+            </a:pPr>
+            <a:r>
+              <a:rPr b="1" i="0" lang="en-US" sz="1200" u="none" cap="none" strike="noStrike">
+                <a:solidFill>
+                  <a:srgbClr val="0369A1"/>
+                </a:solidFill>
+                <a:latin typeface="Calibri"/>
+                <a:ea typeface="Calibri"/>
+                <a:cs typeface="Calibri"/>
+                <a:sym typeface="Calibri"/>
+              </a:rPr>
+              <a:t>TAXONOMY SELF-CORRECTION</a:t>
+            </a:r>
+            <a:endParaRPr/>
+          </a:p>
+        </p:txBody>
+      </p:sp>
+      <p:sp>
+        <p:nvSpPr>
+          <p:cNvPr id="109" name="Google Shape;109;p15"/>
+          <p:cNvSpPr txBox="1"/>
+          <p:nvPr/>
+        </p:nvSpPr>
+        <p:spPr>
+          <a:xfrm>
+            <a:off x="457200" y="960120"/>
+            <a:ext cx="11247120" cy="777240"/>
+          </a:xfrm>
+          <a:prstGeom prst="rect">
+            <a:avLst/>
+          </a:prstGeom>
+          <a:noFill/>
+          <a:ln>
+            <a:noFill/>
+          </a:ln>
+        </p:spPr>
+        <p:txBody>
+          <a:bodyPr anchorCtr="0" anchor="t" bIns="0" lIns="0" spcFirstLastPara="1" rIns="0" wrap="square" tIns="0">
+            <a:spAutoFit/>
+          </a:bodyPr>
+          <a:lstStyle/>
+          <a:p>
+            <a:pPr indent="0" lvl="0" marL="0" marR="0" rtl="0" algn="l">
+              <a:spcBef>
+                <a:spcPts val="0"/>
+              </a:spcBef>
+              <a:spcAft>
+                <a:spcPts val="0"/>
+              </a:spcAft>
+              <a:buNone/>
+            </a:pPr>
+            <a:r>
+              <a:rPr b="1" i="0" lang="en-US" sz="3200" u="none" cap="none" strike="noStrike">
+                <a:solidFill>
+                  <a:srgbClr val="0A2540"/>
+                </a:solidFill>
+                <a:latin typeface="Calibri"/>
+                <a:ea typeface="Calibri"/>
+                <a:cs typeface="Calibri"/>
+                <a:sym typeface="Calibri"/>
+              </a:rPr>
+              <a:t>The agent can fix the catalog, not just the query</a:t>
+            </a:r>
+            <a:endParaRPr/>
+          </a:p>
+        </p:txBody>
+      </p:sp>
+      <p:sp>
+        <p:nvSpPr>
+          <p:cNvPr id="110" name="Google Shape;110;p15"/>
+          <p:cNvSpPr txBox="1"/>
+          <p:nvPr/>
+        </p:nvSpPr>
+        <p:spPr>
+          <a:xfrm>
+            <a:off x="457200" y="2011680"/>
+            <a:ext cx="11247120" cy="914400"/>
+          </a:xfrm>
+          <a:prstGeom prst="rect">
+            <a:avLst/>
+          </a:prstGeom>
+          <a:noFill/>
+          <a:ln>
+            <a:noFill/>
+          </a:ln>
+        </p:spPr>
+        <p:txBody>
+          <a:bodyPr anchorCtr="0" anchor="t" bIns="0" lIns="0" spcFirstLastPara="1" rIns="0" wrap="square" tIns="0">
+            <a:spAutoFit/>
+          </a:bodyPr>
+          <a:lstStyle/>
+          <a:p>
+            <a:pPr indent="0" lvl="0" marL="0" marR="0" rtl="0" algn="l">
+              <a:spcBef>
+                <a:spcPts val="0"/>
+              </a:spcBef>
+              <a:spcAft>
+                <a:spcPts val="0"/>
+              </a:spcAft>
+              <a:buNone/>
+            </a:pPr>
+            <a:r>
+              <a:rPr b="1" i="0" lang="en-US" sz="3800" u="none" cap="none" strike="noStrike">
+                <a:solidFill>
+                  <a:srgbClr val="0A2540"/>
+                </a:solidFill>
+                <a:latin typeface="Calibri"/>
+                <a:ea typeface="Calibri"/>
+                <a:cs typeface="Calibri"/>
+                <a:sym typeface="Calibri"/>
+              </a:rPr>
+              <a:t>A real, verified bug ships in the taxonomy: “tan” maps to “yellow”, not “brown” — 29 products affected.</a:t>
+            </a:r>
+            <a:endParaRPr/>
+          </a:p>
+        </p:txBody>
+      </p:sp>
+      <p:sp>
+        <p:nvSpPr>
+          <p:cNvPr id="111" name="Google Shape;111;p15"/>
+          <p:cNvSpPr txBox="1"/>
+          <p:nvPr/>
+        </p:nvSpPr>
+        <p:spPr>
+          <a:xfrm>
+            <a:off x="457200" y="3017520"/>
+            <a:ext cx="11247120" cy="822960"/>
+          </a:xfrm>
+          <a:prstGeom prst="rect">
+            <a:avLst/>
+          </a:prstGeom>
+          <a:noFill/>
+          <a:ln>
+            <a:noFill/>
+          </a:ln>
+        </p:spPr>
+        <p:txBody>
+          <a:bodyPr anchorCtr="0" anchor="t" bIns="0" lIns="0" spcFirstLastPara="1" rIns="0" wrap="square" tIns="0">
+            <a:spAutoFit/>
+          </a:bodyPr>
+          <a:lstStyle/>
+          <a:p>
+            <a:pPr indent="0" lvl="0" marL="0" marR="0" rtl="0" algn="l">
+              <a:lnSpc>
+                <a:spcPct val="120000"/>
+              </a:lnSpc>
+              <a:spcBef>
+                <a:spcPts val="0"/>
+              </a:spcBef>
+              <a:spcAft>
+                <a:spcPts val="0"/>
+              </a:spcAft>
+              <a:buNone/>
+            </a:pPr>
+            <a:r>
+              <a:rPr b="0" i="0" lang="en-US" sz="1800" u="none" cap="none" strike="noStrike">
+                <a:solidFill>
+                  <a:srgbClr val="475569"/>
+                </a:solidFill>
+                <a:latin typeface="Calibri"/>
+                <a:ea typeface="Calibri"/>
+                <a:cs typeface="Calibri"/>
+                <a:sym typeface="Calibri"/>
+              </a:rPr>
+              <a:t>Passes the quality gate confidently, tagged yellow not brown. A shopper disputes it — the agent verifies, corrects the mapping, and triggers a real ~19–20s re-index.</a:t>
+            </a:r>
+            <a:endParaRPr/>
+          </a:p>
+        </p:txBody>
+      </p:sp>
+      <p:sp>
+        <p:nvSpPr>
+          <p:cNvPr id="112" name="Google Shape;112;p15"/>
+          <p:cNvSpPr/>
+          <p:nvPr/>
+        </p:nvSpPr>
+        <p:spPr>
+          <a:xfrm>
+            <a:off x="457200" y="4343400"/>
+            <a:ext cx="11247120" cy="1737360"/>
+          </a:xfrm>
+          <a:prstGeom prst="rect">
+            <a:avLst/>
+          </a:prstGeom>
+          <a:solidFill>
+            <a:srgbClr val="F8FAFC"/>
+          </a:solidFill>
+          <a:ln>
+            <a:noFill/>
+          </a:ln>
+        </p:spPr>
+        <p:txBody>
+          <a:bodyPr anchorCtr="0" anchor="ctr" bIns="45700" lIns="91425" spcFirstLastPara="1" rIns="91425" wrap="square" tIns="45700">
+            <a:noAutofit/>
+          </a:bodyPr>
+          <a:lstStyle/>
+          <a:p>
+            <a:pPr indent="0" lvl="0" marL="0" marR="0" rtl="0" algn="ctr">
+              <a:spcBef>
+                <a:spcPts val="0"/>
+              </a:spcBef>
+              <a:spcAft>
+                <a:spcPts val="0"/>
+              </a:spcAft>
+              <a:buNone/>
+            </a:pPr>
+            <a:r>
+              <a:t/>
+            </a:r>
+            <a:endParaRPr b="0" i="0" sz="1800" u="none" cap="none" strike="noStrike">
+              <a:solidFill>
+                <a:schemeClr val="dk1"/>
+              </a:solidFill>
+              <a:latin typeface="Calibri"/>
+              <a:ea typeface="Calibri"/>
+              <a:cs typeface="Calibri"/>
+              <a:sym typeface="Calibri"/>
+            </a:endParaRPr>
+          </a:p>
+        </p:txBody>
+      </p:sp>
+      <p:sp>
+        <p:nvSpPr>
+          <p:cNvPr id="113" name="Google Shape;113;p15"/>
+          <p:cNvSpPr txBox="1"/>
+          <p:nvPr/>
+        </p:nvSpPr>
+        <p:spPr>
+          <a:xfrm>
+            <a:off x="731520" y="4526280"/>
+            <a:ext cx="10698480" cy="274320"/>
+          </a:xfrm>
+          <a:prstGeom prst="rect">
+            <a:avLst/>
+          </a:prstGeom>
+          <a:noFill/>
+          <a:ln>
+            <a:noFill/>
+          </a:ln>
+        </p:spPr>
+        <p:txBody>
+          <a:bodyPr anchorCtr="0" anchor="t" bIns="0" lIns="0" spcFirstLastPara="1" rIns="0" wrap="square" tIns="0">
+            <a:spAutoFit/>
+          </a:bodyPr>
+          <a:lstStyle/>
+          <a:p>
+            <a:pPr indent="0" lvl="0" marL="0" marR="0" rtl="0" algn="l">
+              <a:spcBef>
+                <a:spcPts val="0"/>
+              </a:spcBef>
+              <a:spcAft>
+                <a:spcPts val="0"/>
+              </a:spcAft>
+              <a:buNone/>
+            </a:pPr>
+            <a:r>
+              <a:rPr b="1" i="0" lang="en-US" sz="1300" u="none" cap="none" strike="noStrike">
+                <a:solidFill>
+                  <a:srgbClr val="0369A1"/>
+                </a:solidFill>
+                <a:latin typeface="Calibri"/>
+                <a:ea typeface="Calibri"/>
+                <a:cs typeface="Calibri"/>
+                <a:sym typeface="Calibri"/>
+              </a:rPr>
+              <a:t>WHY THIS IS THE HARDER CASE</a:t>
+            </a:r>
+            <a:endParaRPr/>
+          </a:p>
+        </p:txBody>
+      </p:sp>
+      <p:sp>
+        <p:nvSpPr>
+          <p:cNvPr id="114" name="Google Shape;114;p15"/>
+          <p:cNvSpPr txBox="1"/>
+          <p:nvPr/>
+        </p:nvSpPr>
+        <p:spPr>
+          <a:xfrm>
+            <a:off x="731520" y="4864608"/>
+            <a:ext cx="10698480" cy="1097280"/>
+          </a:xfrm>
+          <a:prstGeom prst="rect">
+            <a:avLst/>
+          </a:prstGeom>
+          <a:noFill/>
+          <a:ln>
+            <a:noFill/>
+          </a:ln>
+        </p:spPr>
+        <p:txBody>
+          <a:bodyPr anchorCtr="0" anchor="t" bIns="0" lIns="0" spcFirstLastPara="1" rIns="0" wrap="square" tIns="0">
+            <a:spAutoFit/>
+          </a:bodyPr>
+          <a:lstStyle/>
+          <a:p>
+            <a:pPr indent="0" lvl="0" marL="0" marR="0" rtl="0" algn="l">
+              <a:lnSpc>
+                <a:spcPct val="120000"/>
+              </a:lnSpc>
+              <a:spcBef>
+                <a:spcPts val="0"/>
+              </a:spcBef>
+              <a:spcAft>
+                <a:spcPts val="0"/>
+              </a:spcAft>
+              <a:buNone/>
+            </a:pPr>
+            <a:r>
+              <a:rPr b="1" i="0" lang="en-US" sz="1400" u="none" cap="none" strike="noStrike">
+                <a:solidFill>
+                  <a:srgbClr val="0A2540"/>
+                </a:solidFill>
+                <a:latin typeface="Calibri"/>
+                <a:ea typeface="Calibri"/>
+                <a:cs typeface="Calibri"/>
+                <a:sym typeface="Calibri"/>
+              </a:rPr>
+              <a:t>An unrecognized term returns nothing — obvious. A mis-mapped term returns a plausible, confident, wrong result — invisible to any automated check. Only a human catches it.</a:t>
+            </a:r>
+            <a:endParaRPr/>
+          </a:p>
+        </p:txBody>
+      </p:sp>
+    </p:spTree>
+  </p:cSld>
+  <p:clrMapOvr>
+    <a:masterClrMapping/>
+  </p:clrMapOvr>
+</p:sld>
+</file>
+
+<file path=ppt/slides/slide18.xml><?xml version="1.0" encoding="utf-8"?>
+<p:sld xmlns:a="http://schemas.openxmlformats.org/drawingml/2006/main" xmlns:p="http://schemas.openxmlformats.org/presentationml/2006/main" xmlns:r="http://schemas.openxmlformats.org/officeDocument/2006/relationships">
+  <p:cSld>
+    <p:spTree>
+      <p:nvGrpSpPr>
+        <p:cNvPr id="1" name=""/>
+        <p:cNvGrpSpPr/>
+        <p:nvPr/>
+      </p:nvGrpSpPr>
+      <p:grpSpPr/>
+      <p:sp>
+        <p:nvSpPr>
+          <p:cNvPr id="84" name="Google Shape;84;p13"/>
+          <p:cNvSpPr/>
+          <p:nvPr/>
+        </p:nvSpPr>
+        <p:spPr>
+          <a:xfrm>
+            <a:off x="0" y="0"/>
+            <a:ext cx="164592" cy="6858000"/>
+          </a:xfrm>
+          <a:prstGeom prst="rect">
+            <a:avLst/>
+          </a:prstGeom>
+          <a:solidFill>
+            <a:srgbClr val="0EA5E9"/>
+          </a:solidFill>
+          <a:ln>
+            <a:noFill/>
+          </a:ln>
+        </p:spPr>
+        <p:txBody>
+          <a:bodyPr anchorCtr="0" anchor="ctr" bIns="45700" lIns="91425" spcFirstLastPara="1" rIns="91425" wrap="square" tIns="45700">
+            <a:noAutofit/>
+          </a:bodyPr>
+          <a:lstStyle/>
+          <a:p>
+            <a:pPr indent="0" lvl="0" marL="0" marR="0" rtl="0" algn="ctr">
+              <a:spcBef>
+                <a:spcPts val="0"/>
+              </a:spcBef>
+              <a:spcAft>
+                <a:spcPts val="0"/>
+              </a:spcAft>
+              <a:buNone/>
+            </a:pPr>
+            <a:r>
+              <a:t/>
+            </a:r>
+            <a:endParaRPr b="0" i="0" sz="1800" u="none" cap="none" strike="noStrike">
+              <a:solidFill>
+                <a:schemeClr val="dk1"/>
+              </a:solidFill>
+              <a:latin typeface="Calibri"/>
+              <a:ea typeface="Calibri"/>
+              <a:cs typeface="Calibri"/>
+              <a:sym typeface="Calibri"/>
+            </a:endParaRPr>
+          </a:p>
+        </p:txBody>
+      </p:sp>
+      <p:sp>
+        <p:nvSpPr>
+          <p:cNvPr id="85" name="Google Shape;85;p13"/>
+          <p:cNvSpPr txBox="1"/>
+          <p:nvPr/>
+        </p:nvSpPr>
+        <p:spPr>
+          <a:xfrm>
+            <a:off x="640080" y="1920240"/>
+            <a:ext cx="7315200" cy="320040"/>
+          </a:xfrm>
+          <a:prstGeom prst="rect">
+            <a:avLst/>
+          </a:prstGeom>
+          <a:noFill/>
+          <a:ln>
+            <a:noFill/>
+          </a:ln>
+        </p:spPr>
+        <p:txBody>
+          <a:bodyPr anchorCtr="0" anchor="t" bIns="0" lIns="0" spcFirstLastPara="1" rIns="0" wrap="square" tIns="0">
+            <a:spAutoFit/>
+          </a:bodyPr>
+          <a:lstStyle/>
+          <a:p>
+            <a:pPr indent="0" lvl="0" marL="0" marR="0" rtl="0" algn="l">
+              <a:spcBef>
+                <a:spcPts val="0"/>
+              </a:spcBef>
+              <a:spcAft>
+                <a:spcPts val="0"/>
+              </a:spcAft>
+              <a:buNone/>
+            </a:pPr>
+            <a:r>
+              <a:rPr b="1" i="0" lang="en-US" sz="1500" u="none" cap="none" strike="noStrike">
+                <a:solidFill>
+                  <a:srgbClr val="0EA5E9"/>
+                </a:solidFill>
+                <a:latin typeface="Calibri"/>
+                <a:ea typeface="Calibri"/>
+                <a:cs typeface="Calibri"/>
+                <a:sym typeface="Calibri"/>
+              </a:rPr>
+              <a:t>TRANSITION</a:t>
+            </a:r>
+            <a:endParaRPr/>
+          </a:p>
+        </p:txBody>
+      </p:sp>
+      <p:sp>
+        <p:nvSpPr>
+          <p:cNvPr id="86" name="Google Shape;86;p13"/>
+          <p:cNvSpPr txBox="1"/>
+          <p:nvPr/>
+        </p:nvSpPr>
+        <p:spPr>
+          <a:xfrm>
+            <a:off x="640080" y="2331720"/>
+            <a:ext cx="10972800" cy="868680"/>
+          </a:xfrm>
+          <a:prstGeom prst="rect">
+            <a:avLst/>
+          </a:prstGeom>
+          <a:noFill/>
+          <a:ln>
+            <a:noFill/>
+          </a:ln>
+        </p:spPr>
+        <p:txBody>
+          <a:bodyPr anchorCtr="0" anchor="t" bIns="0" lIns="0" spcFirstLastPara="1" rIns="0" wrap="square" tIns="0">
+            <a:spAutoFit/>
+          </a:bodyPr>
+          <a:lstStyle/>
+          <a:p>
+            <a:pPr indent="0" lvl="0" marL="0" marR="0" rtl="0" algn="l">
+              <a:spcBef>
+                <a:spcPts val="0"/>
+              </a:spcBef>
+              <a:spcAft>
+                <a:spcPts val="0"/>
+              </a:spcAft>
+              <a:buNone/>
+            </a:pPr>
+            <a:r>
+              <a:rPr b="1" i="0" lang="en-US" sz="5400" u="none" cap="none" strike="noStrike">
+                <a:solidFill>
+                  <a:srgbClr val="FFFFFF"/>
+                </a:solidFill>
+                <a:latin typeface="Calibri"/>
+                <a:ea typeface="Calibri"/>
+                <a:cs typeface="Calibri"/>
+                <a:sym typeface="Calibri"/>
+              </a:rPr>
+              <a:t>Search Relevance Workbench</a:t>
+            </a:r>
+            <a:endParaRPr/>
+          </a:p>
+        </p:txBody>
+      </p:sp>
+      <p:sp>
+        <p:nvSpPr>
+          <p:cNvPr id="87" name="Google Shape;87;p13"/>
+          <p:cNvSpPr txBox="1"/>
+          <p:nvPr/>
+        </p:nvSpPr>
+        <p:spPr>
+          <a:xfrm>
+            <a:off x="640080" y="3136392"/>
+            <a:ext cx="10972800" cy="868680"/>
+          </a:xfrm>
+          <a:prstGeom prst="rect">
+            <a:avLst/>
+          </a:prstGeom>
+          <a:noFill/>
+          <a:ln>
+            <a:noFill/>
+          </a:ln>
+        </p:spPr>
+        <p:txBody>
+          <a:bodyPr anchorCtr="0" anchor="t" bIns="0" lIns="0" spcFirstLastPara="1" rIns="0" wrap="square" tIns="0">
+            <a:spAutoFit/>
+          </a:bodyPr>
+          <a:lstStyle/>
+          <a:p>
+            <a:pPr indent="0" lvl="0" marL="0" marR="0" rtl="0" algn="l">
+              <a:spcBef>
+                <a:spcPts val="0"/>
+              </a:spcBef>
+              <a:spcAft>
+                <a:spcPts val="0"/>
+              </a:spcAft>
+              <a:buNone/>
+            </a:pPr>
+            <a:r>
+              <a:rPr b="1" i="0" lang="en-US" sz="3200" u="none" cap="none" strike="noStrike">
+                <a:solidFill>
+                  <a:srgbClr val="FFFFFF"/>
+                </a:solidFill>
+                <a:latin typeface="Calibri"/>
+                <a:ea typeface="Calibri"/>
+                <a:cs typeface="Calibri"/>
+                <a:sym typeface="Calibri"/>
+              </a:rPr>
+              <a:t>A separate feature tour — independent of what you just saw</a:t>
+            </a:r>
+            <a:endParaRPr/>
+          </a:p>
+        </p:txBody>
+      </p:sp>
+      <p:sp>
+        <p:nvSpPr>
+          <p:cNvPr id="88" name="Google Shape;88;p13"/>
+          <p:cNvSpPr txBox="1"/>
+          <p:nvPr/>
+        </p:nvSpPr>
+        <p:spPr>
+          <a:xfrm>
+            <a:off x="640080" y="4160520"/>
+            <a:ext cx="10972800" cy="411480"/>
+          </a:xfrm>
+          <a:prstGeom prst="rect">
+            <a:avLst/>
+          </a:prstGeom>
+          <a:noFill/>
+          <a:ln>
+            <a:noFill/>
+          </a:ln>
+        </p:spPr>
+        <p:txBody>
+          <a:bodyPr anchorCtr="0" anchor="t" bIns="0" lIns="0" spcFirstLastPara="1" rIns="0" wrap="square" tIns="0">
+            <a:spAutoFit/>
+          </a:bodyPr>
+          <a:lstStyle/>
+          <a:p>
+            <a:pPr indent="0" lvl="0" marL="0" marR="0" rtl="0" algn="l">
+              <a:spcBef>
+                <a:spcPts val="0"/>
+              </a:spcBef>
+              <a:spcAft>
+                <a:spcPts val="0"/>
+              </a:spcAft>
+              <a:buNone/>
+            </a:pPr>
+            <a:r>
+              <a:rPr b="0" i="0" lang="en-US" sz="1600" u="none" cap="none" strike="noStrike">
+                <a:solidFill>
+                  <a:srgbClr val="7DD3FC"/>
+                </a:solidFill>
+                <a:latin typeface="Calibri"/>
+                <a:ea typeface="Calibri"/>
+                <a:cs typeface="Calibri"/>
+                <a:sym typeface="Calibri"/>
+              </a:rPr>
+              <a:t>That was our custom LangGraph application improving a search — and fixing its own catalog — in real time. Separately, the latest OpenSearch release provides Search Relevance Workbench features for relevance engineers working in Dashboards. Let's take a short tour.</a:t>
+            </a:r>
+            <a:endParaRPr/>
+          </a:p>
+        </p:txBody>
+      </p:sp>
+      <p:sp>
+        <p:nvSpPr>
+          <p:cNvPr id="89" name="Google Shape;89;p13"/>
+          <p:cNvSpPr txBox="1"/>
+          <p:nvPr/>
+        </p:nvSpPr>
+        <p:spPr>
+          <a:xfrm>
+            <a:off x="640080" y="5166360"/>
+            <a:ext cx="10972800" cy="365760"/>
+          </a:xfrm>
+          <a:prstGeom prst="rect">
+            <a:avLst/>
+          </a:prstGeom>
+          <a:noFill/>
+          <a:ln>
+            <a:noFill/>
+          </a:ln>
+        </p:spPr>
+        <p:txBody>
+          <a:bodyPr anchorCtr="0" anchor="t" bIns="0" lIns="0" spcFirstLastPara="1" rIns="0" wrap="square" tIns="0">
+            <a:spAutoFit/>
+          </a:bodyPr>
+          <a:lstStyle/>
+          <a:p>
+            <a:pPr indent="0" lvl="0" marL="0" marR="0" rtl="0" algn="l">
+              <a:spcBef>
+                <a:spcPts val="0"/>
+              </a:spcBef>
+              <a:spcAft>
+                <a:spcPts val="0"/>
+              </a:spcAft>
+              <a:buNone/>
+            </a:pPr>
+            <a:r>
+              <a:rPr b="1" i="0" lang="en-US" sz="1800" u="none" cap="none" strike="noStrike">
+                <a:solidFill>
+                  <a:srgbClr val="FFFFFF"/>
+                </a:solidFill>
+                <a:latin typeface="Calibri"/>
+                <a:ea typeface="Calibri"/>
+                <a:cs typeface="Calibri"/>
+                <a:sym typeface="Calibri"/>
+              </a:rPr>
+              <a:t>Demo B</a:t>
+            </a:r>
+            <a:endParaRPr/>
+          </a:p>
+        </p:txBody>
+      </p:sp>
+      <p:sp>
+        <p:nvSpPr>
+          <p:cNvPr id="90" name="Google Shape;90;p13"/>
+          <p:cNvSpPr txBox="1"/>
+          <p:nvPr/>
+        </p:nvSpPr>
+        <p:spPr>
+          <a:xfrm>
+            <a:off x="640080" y="5559552"/>
+            <a:ext cx="7315200" cy="274320"/>
+          </a:xfrm>
+          <a:prstGeom prst="rect">
+            <a:avLst/>
+          </a:prstGeom>
+          <a:noFill/>
+          <a:ln>
+            <a:noFill/>
+          </a:ln>
+        </p:spPr>
+        <p:txBody>
+          <a:bodyPr anchorCtr="0" anchor="t" bIns="0" lIns="0" spcFirstLastPara="1" rIns="0" wrap="square" tIns="0">
+            <a:spAutoFit/>
+          </a:bodyPr>
+          <a:lstStyle/>
+          <a:p>
+            <a:pPr indent="0" lvl="0" marL="0" marR="0" rtl="0" algn="l">
+              <a:spcBef>
+                <a:spcPts val="0"/>
+              </a:spcBef>
+              <a:spcAft>
+                <a:spcPts val="0"/>
+              </a:spcAft>
+              <a:buNone/>
+            </a:pPr>
+            <a:r>
+              <a:rPr b="0" i="0" lang="en-US" sz="1500" u="none" cap="none" strike="noStrike">
+                <a:solidFill>
+                  <a:srgbClr val="B8C5D1"/>
+                </a:solidFill>
+                <a:latin typeface="Calibri"/>
+                <a:ea typeface="Calibri"/>
+                <a:cs typeface="Calibri"/>
+                <a:sym typeface="Calibri"/>
+              </a:rPr>
+              <a:t>Nothing here depends on, validates, or configures Demo A</a:t>
+            </a:r>
+            <a:endParaRPr/>
+          </a:p>
+        </p:txBody>
+      </p:sp>
+      <p:sp>
+        <p:nvSpPr>
+          <p:cNvPr id="91" name="Google Shape;91;p13"/>
+          <p:cNvSpPr txBox="1"/>
+          <p:nvPr/>
+        </p:nvSpPr>
+        <p:spPr>
+          <a:xfrm>
+            <a:off x="640080" y="5870448"/>
+            <a:ext cx="7315200" cy="274320"/>
+          </a:xfrm>
+          <a:prstGeom prst="rect">
+            <a:avLst/>
+          </a:prstGeom>
+          <a:noFill/>
+          <a:ln>
+            <a:noFill/>
+          </a:ln>
+        </p:spPr>
+        <p:txBody>
+          <a:bodyPr anchorCtr="0" anchor="t" bIns="0" lIns="0" spcFirstLastPara="1" rIns="0" wrap="square" tIns="0">
+            <a:spAutoFit/>
+          </a:bodyPr>
+          <a:lstStyle/>
+          <a:p>
+            <a:pPr indent="0" lvl="0" marL="0" marR="0" rtl="0" algn="l">
+              <a:spcBef>
+                <a:spcPts val="0"/>
+              </a:spcBef>
+              <a:spcAft>
+                <a:spcPts val="0"/>
+              </a:spcAft>
+              <a:buNone/>
+            </a:pPr>
+            <a:r>
+              <a:rPr b="0" i="0" lang="en-US" sz="1100" u="none" cap="none" strike="noStrike">
+                <a:solidFill>
+                  <a:srgbClr val="0EA5E9"/>
+                </a:solidFill>
+                <a:latin typeface="Calibri"/>
+                <a:ea typeface="Calibri"/>
+                <a:cs typeface="Calibri"/>
+                <a:sym typeface="Calibri"/>
+              </a:rPr>
+              <a:t>github.com/kmwtechnology/opensearch2026-agentic-search</a:t>
+            </a:r>
+            <a:endParaRPr/>
+          </a:p>
+        </p:txBody>
+      </p:sp>
+      <p:sp>
+        <p:nvSpPr>
+          <p:cNvPr id="92" name="Google Shape;92;p13"/>
+          <p:cNvSpPr txBox="1"/>
+          <p:nvPr/>
+        </p:nvSpPr>
+        <p:spPr>
+          <a:xfrm>
+            <a:off x="7772400" y="6446520"/>
+            <a:ext cx="4114800" cy="274320"/>
+          </a:xfrm>
+          <a:prstGeom prst="rect">
+            <a:avLst/>
+          </a:prstGeom>
+          <a:noFill/>
+          <a:ln>
+            <a:noFill/>
+          </a:ln>
+        </p:spPr>
+        <p:txBody>
+          <a:bodyPr anchorCtr="0" anchor="t" bIns="0" lIns="0" spcFirstLastPara="1" rIns="0" wrap="square" tIns="0">
+            <a:spAutoFit/>
+          </a:bodyPr>
+          <a:lstStyle/>
+          <a:p>
+            <a:pPr indent="0" lvl="0" marL="0" marR="0" rtl="0" algn="r">
+              <a:spcBef>
+                <a:spcPts val="0"/>
+              </a:spcBef>
+              <a:spcAft>
+                <a:spcPts val="0"/>
+              </a:spcAft>
+              <a:buNone/>
+            </a:pPr>
+            <a:r>
+              <a:rPr b="0" i="0" lang="en-US" sz="1000" u="none" cap="none" strike="noStrike">
+                <a:solidFill>
+                  <a:srgbClr val="7B8C9F"/>
+                </a:solidFill>
+                <a:latin typeface="Calibri"/>
+                <a:ea typeface="Calibri"/>
+                <a:cs typeface="Calibri"/>
+                <a:sym typeface="Calibri"/>
+              </a:rPr>
+              <a:t>OpenSearchCon North America 2026</a:t>
+            </a:r>
+            <a:endParaRPr/>
+          </a:p>
+        </p:txBody>
+      </p:sp>
+    </p:spTree>
+  </p:cSld>
+  <p:clrMapOvr>
+    <a:masterClrMapping/>
+  </p:clrMapOvr>
+</p:sld>
+</file>
+
 <file path=ppt/slides/slide2.xml><?xml version="1.0" encoding="utf-8"?>
 <p:sld xmlns:a="http://schemas.openxmlformats.org/drawingml/2006/main" xmlns:p="http://schemas.openxmlformats.org/presentationml/2006/main" xmlns:r="http://schemas.openxmlformats.org/officeDocument/2006/relationships">
   <p:cSld>
@@ -17671,7 +18932,7 @@
                 <a:cs typeface="Calibri"/>
                 <a:sym typeface="Calibri"/>
               </a:rPr>
-              <a:t>2 / 16</a:t>
+              <a:t>2 / 18</a:t>
             </a:r>
             <a:endParaRPr/>
           </a:p>
@@ -18160,7 +19421,7 @@
                 <a:cs typeface="Calibri"/>
                 <a:sym typeface="Calibri"/>
               </a:rPr>
-              <a:t>3 / 16</a:t>
+              <a:t>4 / 18</a:t>
             </a:r>
             <a:endParaRPr/>
           </a:p>
@@ -18360,7 +19621,7 @@
                 <a:cs typeface="Calibri"/>
                 <a:sym typeface="Calibri"/>
               </a:rPr>
-              <a:t>When it can improve results on the fly.</a:t>
+              <a:t>A search agent becomes genuinely agentic in two distinct ways.</a:t>
             </a:r>
             <a:endParaRPr/>
           </a:p>
@@ -18413,7 +19674,7 @@
                 <a:cs typeface="Calibri"/>
                 <a:sym typeface="Calibri"/>
               </a:rPr>
-              <a:t>Try a bounded set of retrieval strategies · score them with real judgments · choose the best evidence · recover once when needed · verify the final answer.</a:t>
+              <a:t>(1) It can improve results on the fly — classify intent, weight retrieval dynamically, retry once when confidence is low, verify its own answer. (2) It can recognize when the catalog itself is wrong — not the query — and fix that: not just teach the index a term it's never seen, but correct a term it already has wrong, live. The second is harder and more honest — the wrong result passes the quality gate with a confident score; only a human catching it triggers the fix.</a:t>
             </a:r>
             <a:endParaRPr/>
           </a:p>
@@ -18579,7 +19840,7 @@
                 <a:cs typeface="Calibri"/>
                 <a:sym typeface="Calibri"/>
               </a:rPr>
-              <a:t>Search Relevance Workbench imports it for its feature demonstration; LangGraph reads the same judgments directly at runtime to score attempts and steer the agent. </a:t>
+              <a:t>Search Relevance Workbench imports it for its feature demonstration; LangGraph reads the same judgments opportunistically as a diagnostic — never to steer retry, routing, or ranking, which are driven entirely by reranker confidence. </a:t>
             </a:r>
             <a:r>
               <a:rPr b="1" i="0" lang="en-US" sz="1400" u="none" cap="none" strike="noStrike">
@@ -18673,7 +19934,7 @@
                 <a:cs typeface="Calibri"/>
                 <a:sym typeface="Calibri"/>
               </a:rPr>
-              <a:t>4 / 16</a:t>
+              <a:t>5 / 18</a:t>
             </a:r>
             <a:endParaRPr/>
           </a:p>
@@ -19028,7 +20289,7 @@
                 <a:cs typeface="Calibri"/>
                 <a:sym typeface="Calibri"/>
               </a:rPr>
-              <a:t>Accepts only exact judged queries for the conference demo</a:t>
+              <a:t>Accepts any natural-language query — judgments consulted opportunistically when a match exists</a:t>
             </a:r>
             <a:endParaRPr/>
           </a:p>
@@ -19067,7 +20328,7 @@
                 <a:cs typeface="Calibri"/>
                 <a:sym typeface="Calibri"/>
               </a:rPr>
-              <a:t>Runs multiple strategies, computes metrics, selects a winner, optionally recovers once</a:t>
+              <a:t>Classifies intent, weights retrieval dynamically (α), retries once if confidence is low</a:t>
             </a:r>
             <a:endParaRPr/>
           </a:p>
@@ -19107,6 +20368,45 @@
                 <a:sym typeface="Calibri"/>
               </a:rPr>
               <a:t>Curates evidence, generates, critiques, and optionally repairs the answer once</a:t>
+            </a:r>
+            <a:endParaRPr/>
+          </a:p>
+          <a:p>
+            <a:pPr indent="0" lvl="0" marL="0" marR="0" rtl="0" algn="l">
+              <a:lnSpc>
+                <a:spcPct val="110000"/>
+              </a:lnSpc>
+              <a:spcBef>
+                <a:spcPts val="500"/>
+              </a:spcBef>
+              <a:spcAft>
+                <a:spcPts val="0"/>
+              </a:spcAft>
+              <a:buNone/>
+            </a:pPr>
+            <a:r>
+              <a:rPr b="1" i="0" lang="en-US" sz="1200" u="none" cap="none" strike="noStrike">
+                <a:solidFill>
+                  <a:srgbClr val="0EA5E9"/>
+                </a:solidFill>
+                <a:latin typeface="Calibri"/>
+                <a:ea typeface="Calibri"/>
+                <a:cs typeface="Calibri"/>
+                <a:sym typeface="Calibri"/>
+              </a:rPr>
+              <a:t>•  </a:t>
+            </a:r>
+            <a:r>
+              <a:rPr b="0" i="0" lang="en-US" sz="1200" u="none" cap="none" strike="noStrike">
+                <a:solidFill>
+                  <a:srgbClr val="475569"/>
+                </a:solidFill>
+                <a:latin typeface="Calibri"/>
+                <a:ea typeface="Calibri"/>
+                <a:cs typeface="Calibri"/>
+                <a:sym typeface="Calibri"/>
+              </a:rPr>
+              <a:t>Can also correct the catalog itself, live — the centerpiece</a:t>
             </a:r>
             <a:endParaRPr/>
           </a:p>
@@ -19619,7 +20919,7 @@
                 <a:cs typeface="Calibri"/>
                 <a:sym typeface="Calibri"/>
               </a:rPr>
-              <a:t>5 / 16</a:t>
+              <a:t>3 / 18</a:t>
             </a:r>
             <a:endParaRPr/>
           </a:p>
@@ -20170,7 +21470,7 @@
                 <a:cs typeface="Calibri"/>
                 <a:sym typeface="Calibri"/>
               </a:rPr>
-              <a:t>6 / 16</a:t>
+              <a:t>6 / 18</a:t>
             </a:r>
             <a:endParaRPr/>
           </a:p>
@@ -20547,7 +21847,7 @@
                 <a:cs typeface="Calibri"/>
                 <a:sym typeface="Calibri"/>
               </a:rPr>
-              <a:t>the live demo accepts only exact judged queries, so every attempt can be scored.</a:t>
+              <a:t>the live demo accepts any query. An exact judgment match shows NDCG@10/MRR/Recall@20/Precision@10; otherwise a confidence proxy (top-1 score, score gap, variance, rank churn) fills in.</a:t>
             </a:r>
           </a:p>
           <a:p>
@@ -20597,7 +21897,7 @@
                 <a:cs typeface="Calibri"/>
                 <a:sym typeface="Calibri"/>
               </a:rPr>
-              <a:t>judged product IDs are never injected into retrieval — each strategy earns its ranking.</a:t>
+              <a:t>judged product IDs are never injected into retrieval — results are earned by the same hybrid search every query gets.</a:t>
             </a:r>
           </a:p>
           <a:p>
@@ -20647,7 +21947,7 @@
                 <a:cs typeface="Calibri"/>
                 <a:sym typeface="Calibri"/>
               </a:rPr>
-              <a:t>one recovery round and one answer repair — no unconstrained retries.</a:t>
+              <a:t>one alpha-adjusted quality-gate retry; one LLM-judge auto-correction, only for fabrication or cross-product bleed.</a:t>
             </a:r>
           </a:p>
         </p:txBody>
@@ -20721,7 +22021,7 @@
                 <a:cs typeface="Calibri"/>
                 <a:sym typeface="Calibri"/>
               </a:rPr>
-              <a:t>7 / 16</a:t>
+              <a:t>8 / 18</a:t>
             </a:r>
             <a:endParaRPr/>
           </a:p>
@@ -20948,7 +22248,7 @@
                 <a:cs typeface="Calibri"/>
                 <a:sym typeface="Calibri"/>
               </a:rPr>
-              <a:t>ingests the raw product fields — title, brand, color — through products.conf.</a:t>
+              <a:t>ingests the raw product fields through a generated HOCON config, products.generated.conf — regenerated fresh before every run, not a static committed file.</a:t>
             </a:r>
           </a:p>
           <a:p>
@@ -20998,7 +22298,7 @@
                 <a:cs typeface="Calibri"/>
                 <a:sym typeface="Calibri"/>
               </a:rPr>
-              <a:t>a Python stage reads products back from OpenSearch using search_after pagination.</a:t>
+              <a:t>attribute detection happens inside the ingest pipeline itself — AttributeDetectorStage, one generic Java stage parameterized by attribute type, in a single pass.</a:t>
             </a:r>
           </a:p>
           <a:p>
@@ -21048,7 +22348,7 @@
                 <a:cs typeface="Calibri"/>
                 <a:sym typeface="Calibri"/>
               </a:rPr>
-              <a:t>16 canonical colors, synonym expansion (grey → gray), compound extraction (“Black &amp; Purple” → primary black, secondary purple), brand case-folding.</a:t>
+              <a:t>the taxonomy (which variants map to which canonical bucket, for color and material) lives in OpenSearch, not a committed file. A new attribute type needs zero new Java code.</a:t>
             </a:r>
           </a:p>
           <a:p>
@@ -21098,7 +22398,7 @@
                 <a:cs typeface="Calibri"/>
                 <a:sym typeface="Calibri"/>
               </a:rPr>
-              <a:t>product_color_primary, product_color_secondary, product_brand_normalized.</a:t>
+              <a:t>product_color_primary/_secondary, product_material_primary/_secondary; brand handled separately by BrandNormalizerStage.</a:t>
             </a:r>
           </a:p>
           <a:p>
@@ -21198,7 +22498,7 @@
                 <a:cs typeface="Calibri"/>
                 <a:sym typeface="Calibri"/>
               </a:rPr>
-              <a:t>“blue backpacks” now matches Navy and Cyan variants — a retrieval problem query tuning alone could not solve.</a:t>
+              <a:t>“blue backpacks” now matches Navy and Cyan variants — that's growth. The harder, more interesting case: correcting a term the index already has wrong.</a:t>
             </a:r>
           </a:p>
         </p:txBody>
@@ -21279,7 +22579,7 @@
                 <a:cs typeface="Calibri"/>
                 <a:sym typeface="Calibri"/>
               </a:rPr>
-              <a:t>8 / 16</a:t>
+              <a:t>10 / 18</a:t>
             </a:r>
             <a:endParaRPr/>
           </a:p>
@@ -21530,7 +22830,7 @@
                 <a:cs typeface="Calibri"/>
                 <a:sym typeface="Calibri"/>
               </a:rPr>
-              <a:t>RETRIEVAL · STRATEGY TOURNAMENT</a:t>
+              <a:t>PIPELINE</a:t>
             </a:r>
             <a:endParaRPr/>
           </a:p>
@@ -21595,7 +22895,7 @@
                 <a:cs typeface="Calibri"/>
                 <a:sym typeface="Calibri"/>
               </a:rPr>
-              <a:t>Optimized BM25, balanced hybrid, lexical-heavy, semantic-heavy — in parallel</a:t>
+              <a:t>Intent classifier (6 classes) → query rewriter (follow-ups) → query evaluator (sets α)</a:t>
             </a:r>
           </a:p>
           <a:p>
@@ -21633,7 +22933,7 @@
                 <a:cs typeface="Calibri"/>
                 <a:sym typeface="Calibri"/>
               </a:rPr>
-              <a:t>Same index, filters, candidate budget, and reranker for a fair comparison</a:t>
+              <a:t>→ retriever: one hybrid BM25+vector pass, RRF fusion (k=60)</a:t>
             </a:r>
           </a:p>
           <a:p>
@@ -21671,7 +22971,7 @@
                 <a:cs typeface="Calibri"/>
                 <a:sym typeface="Calibri"/>
               </a:rPr>
-              <a:t>Every pre- and post-rerank attempt kept in an append-only history</a:t>
+              <a:t>→ reranker (cross-encoder, scores 0.0–1.0) → agent (cited generation) → LLM judge</a:t>
             </a:r>
           </a:p>
         </p:txBody>
@@ -21771,7 +23071,7 @@
                 <a:cs typeface="Calibri"/>
                 <a:sym typeface="Calibri"/>
               </a:rPr>
-              <a:t>SELECTION · SCORE, PICK, RECOVER</a:t>
+              <a:t>QUALITY GATE</a:t>
             </a:r>
             <a:endParaRPr/>
           </a:p>
@@ -21836,7 +23136,7 @@
                 <a:cs typeface="Calibri"/>
                 <a:sym typeface="Calibri"/>
               </a:rPr>
-              <a:t>NDCG@10 is the objective; MRR, Recall@20, Precision@10, latency break ties</a:t>
+              <a:t>Reranker max score vs. an intent-specific threshold (0.45–0.55)</a:t>
             </a:r>
           </a:p>
           <a:p>
@@ -21874,7 +23174,7 @@
                 <a:cs typeface="Calibri"/>
                 <a:sym typeface="Calibri"/>
               </a:rPr>
-              <a:t>The best measured attempt wins — not the most confident one</a:t>
+              <a:t>Below threshold: retry once, alpha adjusted toward the opposite end</a:t>
             </a:r>
           </a:p>
           <a:p>
@@ -21912,7 +23212,7 @@
                 <a:cs typeface="Calibri"/>
                 <a:sym typeface="Calibri"/>
               </a:rPr>
-              <a:t>One recovery round at most, chosen from the diagnostic that failed</a:t>
+              <a:t>A bounded single retry — not an open-ended recovery loop</a:t>
             </a:r>
           </a:p>
         </p:txBody>
@@ -22012,7 +23312,7 @@
                 <a:cs typeface="Calibri"/>
                 <a:sym typeface="Calibri"/>
               </a:rPr>
-              <a:t>GENERATION · CURATE, WRITE, CRITIQUE</a:t>
+              <a:t>GENERATE &amp; VERIFY</a:t>
             </a:r>
             <a:endParaRPr/>
           </a:p>
@@ -22077,7 +23377,7 @@
                 <a:cs typeface="Calibri"/>
                 <a:sym typeface="Calibri"/>
               </a:rPr>
-              <a:t>Context from Exact and Substitute first; Complement as support; Irrelevant excluded</a:t>
+              <a:t>Context built strictly from each retrieved product's own facts</a:t>
             </a:r>
           </a:p>
           <a:p>
@@ -22115,7 +23415,7 @@
                 <a:cs typeface="Calibri"/>
                 <a:sym typeface="Calibri"/>
               </a:rPr>
-              <a:t>Cited answer generated from the selected evidence only</a:t>
+              <a:t>Cited answer generated, then checked by an LLM judge for hallucination</a:t>
             </a:r>
           </a:p>
           <a:p>
@@ -22153,7 +23453,7 @@
                 <a:cs typeface="Calibri"/>
                 <a:sym typeface="Calibri"/>
               </a:rPr>
-              <a:t>Critic checks faithfulness, relevance, citations, coverage — one repair allowed</a:t>
+              <a:t>One bounded auto-correction, only for fabrication or cross-product bleed</a:t>
             </a:r>
           </a:p>
         </p:txBody>
@@ -22318,7 +23618,7 @@
                 <a:cs typeface="Calibri"/>
                 <a:sym typeface="Calibri"/>
               </a:rPr>
-              <a:t>SearchPlan · RetrievalAttempt · AgentDecision · AnswerEvaluation</a:t>
+              <a:t>CustomAgentState: a single total=False TypedDict — intent, confidence, alpha,</a:t>
             </a:r>
           </a:p>
           <a:p>
@@ -22356,7 +23656,7 @@
                 <a:cs typeface="Calibri"/>
                 <a:sym typeface="Calibri"/>
               </a:rPr>
-              <a:t>Routing is on typed status, never on human-readable reason text</a:t>
+              <a:t>retrieved_documents, reranker_max_score, quality_gate_retried, enrichment_*</a:t>
             </a:r>
           </a:p>
           <a:p>
@@ -22394,7 +23694,45 @@
                 <a:cs typeface="Calibri"/>
                 <a:sym typeface="Calibri"/>
               </a:rPr>
-              <a:t>Every decision is explicit, testable, and inspectable after the run</a:t>
+              <a:t>No separate attempt-scoring contracts were needed — simpler than planned</a:t>
+            </a:r>
+          </a:p>
+          <a:p>
+            <a:pPr indent="0" lvl="0" marL="0" marR="0" rtl="0" algn="l">
+              <a:lnSpc>
+                <a:spcPct val="110000"/>
+              </a:lnSpc>
+              <a:spcBef>
+                <a:spcPts val="500"/>
+              </a:spcBef>
+              <a:spcAft>
+                <a:spcPts val="0"/>
+              </a:spcAft>
+              <a:buNone/>
+            </a:pPr>
+            <a:r>
+              <a:rPr b="1" i="0" lang="en-US" sz="1200" u="none" cap="none" strike="noStrike">
+                <a:solidFill>
+                  <a:srgbClr val="0EA5E9"/>
+                </a:solidFill>
+                <a:latin typeface="Calibri"/>
+                <a:ea typeface="Calibri"/>
+                <a:cs typeface="Calibri"/>
+                <a:sym typeface="Calibri"/>
+              </a:rPr>
+              <a:t>•  </a:t>
+            </a:r>
+            <a:r>
+              <a:rPr b="0" i="0" lang="en-US" sz="1200" u="none" cap="none" strike="noStrike">
+                <a:solidFill>
+                  <a:srgbClr val="475569"/>
+                </a:solidFill>
+                <a:latin typeface="Calibri"/>
+                <a:ea typeface="Calibri"/>
+                <a:cs typeface="Calibri"/>
+                <a:sym typeface="Calibri"/>
+              </a:rPr>
+              <a:t>Layered on top: taxonomy self-correction — trigger_enrichment(attribute_type, variant, canonical), fired by a gap or a correction</a:t>
             </a:r>
           </a:p>
         </p:txBody>
@@ -22475,7 +23813,7 @@
                 <a:cs typeface="Calibri"/>
                 <a:sym typeface="Calibri"/>
               </a:rPr>
-              <a:t>9 / 16</a:t>
+              <a:t>11 / 18</a:t>
             </a:r>
             <a:endParaRPr/>
           </a:p>
@@ -22675,7 +24013,7 @@
                 <a:cs typeface="Calibri"/>
                 <a:sym typeface="Calibri"/>
               </a:rPr>
-              <a:t>1 · Validate &amp; understand</a:t>
+              <a:t>1 · Classify intent</a:t>
             </a:r>
             <a:endParaRPr/>
           </a:p>
@@ -22728,7 +24066,7 @@
                 <a:cs typeface="Calibri"/>
                 <a:sym typeface="Calibri"/>
               </a:rPr>
-              <a:t>Exact match in the judged-query set; normalize, infer constraints, load ESCI labels from OpenSearch. Judged product IDs are never injected — each strategy must earn its ranking.</a:t>
+              <a:t>6 classes, single structured-output call. Confidence &lt;0.7 → clarifying question instead of a guess. Follow-up turns resolve pronouns/comparatives first.</a:t>
             </a:r>
             <a:endParaRPr/>
           </a:p>
@@ -22778,7 +24116,7 @@
                 <a:cs typeface="Calibri"/>
                 <a:sym typeface="Calibri"/>
               </a:rPr>
-              <a:t>2 · Strategy tournament</a:t>
+              <a:t>2 · Weight the query</a:t>
             </a:r>
             <a:endParaRPr/>
           </a:p>
@@ -22831,7 +24169,7 @@
                 <a:cs typeface="Calibri"/>
                 <a:sym typeface="Calibri"/>
               </a:rPr>
-              <a:t>Optimized BM25, balanced hybrid, lexical-heavy, semantic-heavy — in parallel, same index / filters / candidate budget / reranker. Append-only attempt history.</a:t>
+              <a:t>Sets α per query — fast-path defaults for comparison/attribute_filter/refinement, LLM-assessed for search/follow_up.</a:t>
             </a:r>
             <a:endParaRPr/>
           </a:p>
@@ -22881,7 +24219,7 @@
                 <a:cs typeface="Calibri"/>
                 <a:sym typeface="Calibri"/>
               </a:rPr>
-              <a:t>3 · Score &amp; select</a:t>
+              <a:t>3 · Retrieve</a:t>
             </a:r>
             <a:endParaRPr/>
           </a:p>
@@ -22934,7 +24272,7 @@
                 <a:cs typeface="Calibri"/>
                 <a:sym typeface="Calibri"/>
               </a:rPr>
-              <a:t>NDCG@10 primary; MRR, Recall@20, Precision@10, latency as tie-breakers. Best measured attempt wins — never model confidence.</a:t>
+              <a:t>One hybrid BM25+vector pass, RRF fusion (k=60). attribute_filter intent applies taxonomy-backed filters; soft filters relax, hard filters (color/brand) never do.</a:t>
             </a:r>
             <a:endParaRPr/>
           </a:p>
@@ -22984,7 +24322,7 @@
                 <a:cs typeface="Calibri"/>
                 <a:sym typeface="Calibri"/>
               </a:rPr>
-              <a:t>4 · Recover once</a:t>
+              <a:t>4 · Rerank &amp; gate</a:t>
             </a:r>
             <a:endParaRPr/>
           </a:p>
@@ -23037,7 +24375,7 @@
                 <a:cs typeface="Calibri"/>
                 <a:sym typeface="Calibri"/>
               </a:rPr>
-              <a:t>Low Recall@20 → rewrite/expand. Weak NDCG@10 → adjust fusion/reranking. Irrelevant near top → tighten. One extra tournament at most; best across both rounds.</a:t>
+              <a:t>Cross-encoder scores 0–1 against an intent-specific threshold. One alpha-adjusted retry at most — a bounded single retry, not an open-ended loop.</a:t>
             </a:r>
             <a:endParaRPr/>
           </a:p>
@@ -23140,7 +24478,60 @@
                 <a:cs typeface="Calibri"/>
                 <a:sym typeface="Calibri"/>
               </a:rPr>
-              <a:t>Context from Exact + Substitute first; Complement as support; Irrelevant excluded. Cited answer → critic (faithfulness, relevance, citations, coverage) → one bounded repair.</a:t>
+              <a:t>Cited answer from retrieved evidence; LLM judge checks for hallucination, bounded auto-correct for fabrication / cross-product bleed only.</a:t>
+            </a:r>
+            <a:endParaRPr/>
+          </a:p>
+        </p:txBody>
+      </p:sp>
+      <p:sp>
+        <p:nvSpPr>
+          <p:cNvPr id="187" name="Google Shape;186;p19"/>
+          <p:cNvSpPr txBox="1"/>
+          <p:nvPr/>
+        </p:nvSpPr>
+        <p:spPr>
+          <a:xfrm>
+            <a:off x="457200" y="6386791"/>
+            <a:ext cx="11247120" cy="350000"/>
+          </a:xfrm>
+          <a:prstGeom prst="rect">
+            <a:avLst/>
+          </a:prstGeom>
+          <a:noFill/>
+          <a:ln>
+            <a:noFill/>
+          </a:ln>
+        </p:spPr>
+        <p:txBody>
+          <a:bodyPr anchorCtr="0" anchor="t" bIns="0" lIns="0" spcFirstLastPara="1" rIns="0" wrap="square" tIns="0">
+            <a:spAutoFit/>
+          </a:bodyPr>
+          <a:lstStyle/>
+          <a:p>
+            <a:pPr indent="0" lvl="0" marL="0" marR="0" rtl="0" algn="l">
+              <a:lnSpc>
+                <a:spcPct val="110000"/>
+              </a:lnSpc>
+              <a:spcBef>
+                <a:spcPts val="0"/>
+              </a:spcBef>
+              <a:spcAft>
+                <a:spcPts val="0"/>
+              </a:spcAft>
+              <a:buNone/>
+            </a:pPr>
+            <a:r>
+              <a:rPr b="0" i="0" lang="en-US" sz="1200" u="none" cap="none" strike="noStrike">
+                <a:solidFill>
+                  <a:srgbClr val="475569"/>
+                </a:solidFill>
+                <a:latin typeface="Calibri"/>
+                <a:ea typeface="Calibri"/>
+                <a:cs typeface="Calibri"/>
+                <a:sym typeface="Calibri"/>
+              </a:rPr>
+              <a:t>6 · Self-correct the catalog, when disputed — the centerpiece (see next section)</a:t>
             </a:r>
             <a:endParaRPr/>
           </a:p>

</xml_diff>